<commit_message>
ch 6 ! done? maybe..
</commit_message>
<xml_diff>
--- a/lv_readings/images/ctt.pptx
+++ b/lv_readings/images/ctt.pptx
@@ -247,7 +247,7 @@
           <a:p>
             <a:fld id="{03831E2C-BFD0-4A74-B62A-BA7494EC057D}" type="datetimeFigureOut">
               <a:rPr lang="en-GB" smtClean="0"/>
-              <a:t>07/10/2025</a:t>
+              <a:t>10/11/2025</a:t>
             </a:fld>
             <a:endParaRPr lang="en-GB"/>
           </a:p>
@@ -417,7 +417,7 @@
           <a:p>
             <a:fld id="{03831E2C-BFD0-4A74-B62A-BA7494EC057D}" type="datetimeFigureOut">
               <a:rPr lang="en-GB" smtClean="0"/>
-              <a:t>07/10/2025</a:t>
+              <a:t>10/11/2025</a:t>
             </a:fld>
             <a:endParaRPr lang="en-GB"/>
           </a:p>
@@ -597,7 +597,7 @@
           <a:p>
             <a:fld id="{03831E2C-BFD0-4A74-B62A-BA7494EC057D}" type="datetimeFigureOut">
               <a:rPr lang="en-GB" smtClean="0"/>
-              <a:t>07/10/2025</a:t>
+              <a:t>10/11/2025</a:t>
             </a:fld>
             <a:endParaRPr lang="en-GB"/>
           </a:p>
@@ -767,7 +767,7 @@
           <a:p>
             <a:fld id="{03831E2C-BFD0-4A74-B62A-BA7494EC057D}" type="datetimeFigureOut">
               <a:rPr lang="en-GB" smtClean="0"/>
-              <a:t>07/10/2025</a:t>
+              <a:t>10/11/2025</a:t>
             </a:fld>
             <a:endParaRPr lang="en-GB"/>
           </a:p>
@@ -1013,7 +1013,7 @@
           <a:p>
             <a:fld id="{03831E2C-BFD0-4A74-B62A-BA7494EC057D}" type="datetimeFigureOut">
               <a:rPr lang="en-GB" smtClean="0"/>
-              <a:t>07/10/2025</a:t>
+              <a:t>10/11/2025</a:t>
             </a:fld>
             <a:endParaRPr lang="en-GB"/>
           </a:p>
@@ -1245,7 +1245,7 @@
           <a:p>
             <a:fld id="{03831E2C-BFD0-4A74-B62A-BA7494EC057D}" type="datetimeFigureOut">
               <a:rPr lang="en-GB" smtClean="0"/>
-              <a:t>07/10/2025</a:t>
+              <a:t>10/11/2025</a:t>
             </a:fld>
             <a:endParaRPr lang="en-GB"/>
           </a:p>
@@ -1612,7 +1612,7 @@
           <a:p>
             <a:fld id="{03831E2C-BFD0-4A74-B62A-BA7494EC057D}" type="datetimeFigureOut">
               <a:rPr lang="en-GB" smtClean="0"/>
-              <a:t>07/10/2025</a:t>
+              <a:t>10/11/2025</a:t>
             </a:fld>
             <a:endParaRPr lang="en-GB"/>
           </a:p>
@@ -1730,7 +1730,7 @@
           <a:p>
             <a:fld id="{03831E2C-BFD0-4A74-B62A-BA7494EC057D}" type="datetimeFigureOut">
               <a:rPr lang="en-GB" smtClean="0"/>
-              <a:t>07/10/2025</a:t>
+              <a:t>10/11/2025</a:t>
             </a:fld>
             <a:endParaRPr lang="en-GB"/>
           </a:p>
@@ -1825,7 +1825,7 @@
           <a:p>
             <a:fld id="{03831E2C-BFD0-4A74-B62A-BA7494EC057D}" type="datetimeFigureOut">
               <a:rPr lang="en-GB" smtClean="0"/>
-              <a:t>07/10/2025</a:t>
+              <a:t>10/11/2025</a:t>
             </a:fld>
             <a:endParaRPr lang="en-GB"/>
           </a:p>
@@ -2102,7 +2102,7 @@
           <a:p>
             <a:fld id="{03831E2C-BFD0-4A74-B62A-BA7494EC057D}" type="datetimeFigureOut">
               <a:rPr lang="en-GB" smtClean="0"/>
-              <a:t>07/10/2025</a:t>
+              <a:t>10/11/2025</a:t>
             </a:fld>
             <a:endParaRPr lang="en-GB"/>
           </a:p>
@@ -2359,7 +2359,7 @@
           <a:p>
             <a:fld id="{03831E2C-BFD0-4A74-B62A-BA7494EC057D}" type="datetimeFigureOut">
               <a:rPr lang="en-GB" smtClean="0"/>
-              <a:t>07/10/2025</a:t>
+              <a:t>10/11/2025</a:t>
             </a:fld>
             <a:endParaRPr lang="en-GB"/>
           </a:p>
@@ -2572,7 +2572,7 @@
           <a:p>
             <a:fld id="{03831E2C-BFD0-4A74-B62A-BA7494EC057D}" type="datetimeFigureOut">
               <a:rPr lang="en-GB" smtClean="0"/>
-              <a:t>07/10/2025</a:t>
+              <a:t>10/11/2025</a:t>
             </a:fld>
             <a:endParaRPr lang="en-GB"/>
           </a:p>
@@ -4269,7 +4269,7 @@
                   <a:schemeClr val="tx1"/>
                 </a:solidFill>
               </a:rPr>
-              <a:t>ERROR</a:t>
+              <a:t>ERROR 1</a:t>
             </a:r>
           </a:p>
         </p:txBody>
@@ -4659,7 +4659,7 @@
                   <a:schemeClr val="tx1"/>
                 </a:solidFill>
               </a:rPr>
-              <a:t>ERROR</a:t>
+              <a:t>ERROR 2</a:t>
             </a:r>
           </a:p>
         </p:txBody>
@@ -5024,7 +5024,7 @@
             <p:spPr>
               <a:xfrm>
                 <a:off x="11342176" y="1624499"/>
-                <a:ext cx="571182" cy="373179"/>
+                <a:ext cx="493084" cy="373179"/>
               </a:xfrm>
               <a:prstGeom prst="rect">
                 <a:avLst/>
@@ -5068,12 +5068,6 @@
                             </a:rPr>
                             <m:t>𝐸</m:t>
                           </m:r>
-                          <m:r>
-                            <a:rPr lang="en-GB" b="0" i="1" smtClean="0">
-                              <a:latin typeface="Cambria Math" panose="02040503050406030204" pitchFamily="18" charset="0"/>
-                            </a:rPr>
-                            <m:t>1</m:t>
-                          </m:r>
                         </m:sub>
                         <m:sup>
                           <m:r>
@@ -5110,7 +5104,7 @@
             <p:spPr>
               <a:xfrm>
                 <a:off x="11342176" y="1624499"/>
-                <a:ext cx="571182" cy="373179"/>
+                <a:ext cx="493084" cy="373179"/>
               </a:xfrm>
               <a:prstGeom prst="rect">
                 <a:avLst/>
@@ -5154,7 +5148,7 @@
             <p:spPr>
               <a:xfrm>
                 <a:off x="11342176" y="3667687"/>
-                <a:ext cx="571182" cy="373179"/>
+                <a:ext cx="493084" cy="373179"/>
               </a:xfrm>
               <a:prstGeom prst="rect">
                 <a:avLst/>
@@ -5198,12 +5192,6 @@
                             </a:rPr>
                             <m:t>𝐸</m:t>
                           </m:r>
-                          <m:r>
-                            <a:rPr lang="en-GB" b="0" i="1" smtClean="0">
-                              <a:latin typeface="Cambria Math" panose="02040503050406030204" pitchFamily="18" charset="0"/>
-                            </a:rPr>
-                            <m:t>2</m:t>
-                          </m:r>
                         </m:sub>
                         <m:sup>
                           <m:r>
@@ -5240,7 +5228,7 @@
             <p:spPr>
               <a:xfrm>
                 <a:off x="11342176" y="3667687"/>
-                <a:ext cx="571182" cy="373179"/>
+                <a:ext cx="493084" cy="373179"/>
               </a:xfrm>
               <a:prstGeom prst="rect">
                 <a:avLst/>
@@ -5750,8 +5738,8 @@
           </a:fontRef>
         </p:style>
       </p:cxnSp>
-      <mc:AlternateContent xmlns:mc="http://schemas.openxmlformats.org/markup-compatibility/2006">
-        <mc:Choice xmlns:a14="http://schemas.microsoft.com/office/drawing/2010/main" Requires="a14">
+      <mc:AlternateContent xmlns:mc="http://schemas.openxmlformats.org/markup-compatibility/2006" xmlns:a14="http://schemas.microsoft.com/office/drawing/2010/main">
+        <mc:Choice Requires="a14">
           <p:sp>
             <p:nvSpPr>
               <p:cNvPr id="21" name="TextBox 20">
@@ -5829,7 +5817,7 @@
             </p:txBody>
           </p:sp>
         </mc:Choice>
-        <mc:Fallback>
+        <mc:Fallback xmlns="">
           <p:sp>
             <p:nvSpPr>
               <p:cNvPr id="21" name="TextBox 20">
@@ -5874,8 +5862,8 @@
           </p:sp>
         </mc:Fallback>
       </mc:AlternateContent>
-      <mc:AlternateContent xmlns:mc="http://schemas.openxmlformats.org/markup-compatibility/2006">
-        <mc:Choice xmlns:a14="http://schemas.microsoft.com/office/drawing/2010/main" Requires="a14">
+      <mc:AlternateContent xmlns:mc="http://schemas.openxmlformats.org/markup-compatibility/2006" xmlns:a14="http://schemas.microsoft.com/office/drawing/2010/main">
+        <mc:Choice Requires="a14">
           <p:sp>
             <p:nvSpPr>
               <p:cNvPr id="22" name="TextBox 21">
@@ -5953,7 +5941,7 @@
             </p:txBody>
           </p:sp>
         </mc:Choice>
-        <mc:Fallback>
+        <mc:Fallback xmlns="">
           <p:sp>
             <p:nvSpPr>
               <p:cNvPr id="22" name="TextBox 21">
@@ -6532,8 +6520,8 @@
           </a:fontRef>
         </p:style>
       </p:cxnSp>
-      <mc:AlternateContent xmlns:mc="http://schemas.openxmlformats.org/markup-compatibility/2006">
-        <mc:Choice xmlns:a14="http://schemas.microsoft.com/office/drawing/2010/main" Requires="a14">
+      <mc:AlternateContent xmlns:mc="http://schemas.openxmlformats.org/markup-compatibility/2006" xmlns:a14="http://schemas.microsoft.com/office/drawing/2010/main">
+        <mc:Choice Requires="a14">
           <p:sp>
             <p:nvSpPr>
               <p:cNvPr id="21" name="TextBox 20">
@@ -6611,7 +6599,7 @@
             </p:txBody>
           </p:sp>
         </mc:Choice>
-        <mc:Fallback>
+        <mc:Fallback xmlns="">
           <p:sp>
             <p:nvSpPr>
               <p:cNvPr id="21" name="TextBox 20">
@@ -6656,8 +6644,8 @@
           </p:sp>
         </mc:Fallback>
       </mc:AlternateContent>
-      <mc:AlternateContent xmlns:mc="http://schemas.openxmlformats.org/markup-compatibility/2006">
-        <mc:Choice xmlns:a14="http://schemas.microsoft.com/office/drawing/2010/main" Requires="a14">
+      <mc:AlternateContent xmlns:mc="http://schemas.openxmlformats.org/markup-compatibility/2006" xmlns:a14="http://schemas.microsoft.com/office/drawing/2010/main">
+        <mc:Choice Requires="a14">
           <p:sp>
             <p:nvSpPr>
               <p:cNvPr id="22" name="TextBox 21">
@@ -6735,7 +6723,7 @@
             </p:txBody>
           </p:sp>
         </mc:Choice>
-        <mc:Fallback>
+        <mc:Fallback xmlns="">
           <p:sp>
             <p:nvSpPr>
               <p:cNvPr id="22" name="TextBox 21">
@@ -6835,6 +6823,9 @@
                     <a:schemeClr val="tx1"/>
                   </a:solidFill>
                 </a:ln>
+                <a:solidFill>
+                  <a:schemeClr val="tx1"/>
+                </a:solidFill>
               </a:rPr>
               <a:t>0</a:t>
             </a:r>
@@ -6859,6 +6850,114 @@
         <p:spPr>
           <a:xfrm>
             <a:off x="9974449" y="588579"/>
+            <a:ext cx="1" cy="649065"/>
+          </a:xfrm>
+          <a:prstGeom prst="straightConnector1">
+            <a:avLst/>
+          </a:prstGeom>
+          <a:ln w="38100">
+            <a:solidFill>
+              <a:schemeClr val="tx1"/>
+            </a:solidFill>
+            <a:tailEnd type="triangle"/>
+          </a:ln>
+        </p:spPr>
+        <p:style>
+          <a:lnRef idx="1">
+            <a:schemeClr val="accent1"/>
+          </a:lnRef>
+          <a:fillRef idx="0">
+            <a:schemeClr val="accent1"/>
+          </a:fillRef>
+          <a:effectRef idx="0">
+            <a:schemeClr val="accent1"/>
+          </a:effectRef>
+          <a:fontRef idx="minor">
+            <a:schemeClr val="tx1"/>
+          </a:fontRef>
+        </p:style>
+      </p:cxnSp>
+      <p:sp>
+        <p:nvSpPr>
+          <p:cNvPr id="16" name="Isosceles Triangle 15">
+            <a:extLst>
+              <a:ext uri="{FF2B5EF4-FFF2-40B4-BE49-F238E27FC236}">
+                <a16:creationId xmlns:a16="http://schemas.microsoft.com/office/drawing/2014/main" id="{675DED1C-29CC-44F7-897D-DE9184E32BD4}"/>
+              </a:ext>
+            </a:extLst>
+          </p:cNvPr>
+          <p:cNvSpPr/>
+          <p:nvPr/>
+        </p:nvSpPr>
+        <p:spPr>
+          <a:xfrm>
+            <a:off x="1881219" y="136634"/>
+            <a:ext cx="672662" cy="451945"/>
+          </a:xfrm>
+          <a:prstGeom prst="triangle">
+            <a:avLst/>
+          </a:prstGeom>
+          <a:noFill/>
+          <a:ln w="38100">
+            <a:solidFill>
+              <a:schemeClr val="tx1"/>
+            </a:solidFill>
+          </a:ln>
+        </p:spPr>
+        <p:style>
+          <a:lnRef idx="2">
+            <a:schemeClr val="accent1">
+              <a:shade val="50000"/>
+            </a:schemeClr>
+          </a:lnRef>
+          <a:fillRef idx="1">
+            <a:schemeClr val="accent1"/>
+          </a:fillRef>
+          <a:effectRef idx="0">
+            <a:schemeClr val="accent1"/>
+          </a:effectRef>
+          <a:fontRef idx="minor">
+            <a:schemeClr val="lt1"/>
+          </a:fontRef>
+        </p:style>
+        <p:txBody>
+          <a:bodyPr rtlCol="0" anchor="ctr"/>
+          <a:lstStyle/>
+          <a:p>
+            <a:pPr algn="ctr"/>
+            <a:r>
+              <a:rPr lang="en-GB" dirty="0">
+                <a:ln>
+                  <a:solidFill>
+                    <a:schemeClr val="tx1"/>
+                  </a:solidFill>
+                </a:ln>
+                <a:solidFill>
+                  <a:schemeClr val="tx1"/>
+                </a:solidFill>
+              </a:rPr>
+              <a:t>μ</a:t>
+            </a:r>
+          </a:p>
+        </p:txBody>
+      </p:sp>
+      <p:cxnSp>
+        <p:nvCxnSpPr>
+          <p:cNvPr id="17" name="Straight Arrow Connector 16">
+            <a:extLst>
+              <a:ext uri="{FF2B5EF4-FFF2-40B4-BE49-F238E27FC236}">
+                <a16:creationId xmlns:a16="http://schemas.microsoft.com/office/drawing/2014/main" id="{1CA6969B-0DDF-4BD5-9DC7-C0AF295ED3C1}"/>
+              </a:ext>
+            </a:extLst>
+          </p:cNvPr>
+          <p:cNvCxnSpPr>
+            <a:stCxn id="16" idx="3"/>
+          </p:cNvCxnSpPr>
+          <p:nvPr/>
+        </p:nvCxnSpPr>
+        <p:spPr>
+          <a:xfrm>
+            <a:off x="2217550" y="588579"/>
             <a:ext cx="1" cy="649065"/>
           </a:xfrm>
           <a:prstGeom prst="straightConnector1">

</xml_diff>